<commit_message>
style: remove Oxford commas (commas before 'and') from all specs and regenerate deliverables
</commit_message>
<xml_diff>
--- a/project_deliverables/PhaseFinal_Grand-Project-Presentation.pptx
+++ b/project_deliverables/PhaseFinal_Grand-Project-Presentation.pptx
@@ -4182,7 +4182,7 @@
                 </a:solidFill>
                 <a:latin typeface="Arial"/>
               </a:rPr>
-              <a:t>• The Super Manager Bottleneck: One person acts as supervisor, cashier, payroll distributor, and record keeper.</a:t>
+              <a:t>• The Super Manager Bottleneck: One person acts as supervisor, cashier, payroll distributor and record keeper.</a:t>
             </a:r>
           </a:p>
         </p:txBody>
@@ -4418,7 +4418,7 @@
                 </a:solidFill>
                 <a:latin typeface="Arial"/>
               </a:rPr>
-              <a:t>• Direct Observation: The laptop was powered on and actively used during the day. A printer is on site, and physical receipts were being printed for customers as trucks loaded.</a:t>
+              <a:t>• Direct Observation: The laptop was powered on and actively used during the day. A printer is on site and physical receipts were being printed for customers as trucks loaded.</a:t>
             </a:r>
           </a:p>
         </p:txBody>
@@ -4453,7 +4453,7 @@
                 </a:solidFill>
                 <a:latin typeface="Arial"/>
               </a:rPr>
-              <a:t>• Semi Structured Interview: Conducted with the Sales Manager to understand payment channels (Cash, Mobile Money, Bank), tax filing processes, and primary pain points regarding cash insecurity.</a:t>
+              <a:t>• Semi Structured Interview: Conducted with the Sales Manager to understand payment channels (Cash, Mobile Money, Bank), tax filing processes and primary pain points regarding cash insecurity.</a:t>
             </a:r>
           </a:p>
         </p:txBody>
@@ -4654,7 +4654,7 @@
                 </a:solidFill>
                 <a:latin typeface="Arial"/>
               </a:rPr>
-              <a:t>• Inaccessibility: The Business Owner, Site Workers, and Secretary could not be approached directly. These are unresolvable gaps.</a:t>
+              <a:t>• Inaccessibility: The Business Owner, Site Workers and Secretary could not be approached directly. These are unresolvable gaps.</a:t>
             </a:r>
           </a:p>
         </p:txBody>
@@ -4689,7 +4689,7 @@
                 </a:solidFill>
                 <a:latin typeface="Arial"/>
               </a:rPr>
-              <a:t>• No Follow up Feasibility: The Sales Manager was unwilling to provide further information, and a return visit to the site is not possible. The project scope is locked.</a:t>
+              <a:t>• No Follow up Feasibility: The Sales Manager was unwilling to provide further information and a return visit to the site is not possible. The project scope is locked.</a:t>
             </a:r>
           </a:p>
         </p:txBody>
@@ -5021,7 +5021,7 @@
                 </a:solidFill>
                 <a:latin typeface="Arial"/>
               </a:rPr>
-              <a:t>• Phase 1: Real Time Point of Sale. During the day, the system processes individual sales, calculates VAT, updates inventory, and prints physical receipts.</a:t>
+              <a:t>• Phase 1: Real Time Point of Sale. During the day, the system processes individual sales, calculates VAT, updates inventory and prints physical receipts.</a:t>
             </a:r>
           </a:p>
         </p:txBody>
@@ -5056,7 +5056,7 @@
                 </a:solidFill>
                 <a:latin typeface="Arial"/>
               </a:rPr>
-              <a:t>• Phase 2: End of Day Reconciliation. In the evening, the system allows the Sales Manager to balance multi channel payment drawers, log operational expenses, compute cash variances, and generate a final daily summary report for the Business Owner.</a:t>
+              <a:t>• Phase 2: End of Day Reconciliation. In the evening, the system allows the Sales Manager to balance multi channel payment drawers, log operational expenses, compute cash variances and generate a final daily summary report for the Business Owner.</a:t>
             </a:r>
           </a:p>
         </p:txBody>
@@ -5222,7 +5222,7 @@
                 </a:solidFill>
                 <a:latin typeface="Arial"/>
               </a:rPr>
-              <a:t>• Normalization: Database normalized to 3NF to eliminate redundancy across Workers, Attendance, Products, Sales, and Operational Expenses.</a:t>
+              <a:t>• Normalization: Database normalized to 3NF to eliminate redundancy across Workers, Attendance, Products, Sales and Operational Expenses.</a:t>
             </a:r>
           </a:p>
         </p:txBody>

</xml_diff>